<commit_message>
fix(ci): flat repo layout (remove 23_k8s_cicd_monitoring subdir), pin ruff; add local demo runner, runbook, presentation screenshots
</commit_message>
<xml_diff>
--- a/MLOps_Proje_Sunumu.pptx
+++ b/MLOps_Proje_Sunumu.pptx
@@ -15,6 +15,9 @@
     <p:sldId id="263" r:id="rId14"/>
     <p:sldId id="264" r:id="rId15"/>
     <p:sldId id="265" r:id="rId16"/>
+    <p:sldId id="266" r:id="rId17"/>
+    <p:sldId id="267" r:id="rId18"/>
+    <p:sldId id="268" r:id="rId19"/>
   </p:sldIdLst>
   <p:sldSz cx="12191695" cy="6858000" type="screen4x3"/>
   <p:notesSz cx="6858000" cy="9144000"/>
@@ -3346,6 +3349,1264 @@
 </file>
 
 <file path=ppt/slides/slide10.xml><?xml version="1.0" encoding="utf-8"?>
+<p:sld xmlns:a="http://schemas.openxmlformats.org/drawingml/2006/main" xmlns:p="http://schemas.openxmlformats.org/presentationml/2006/main" xmlns:r="http://schemas.openxmlformats.org/officeDocument/2006/relationships">
+  <p:cSld>
+    <p:spTree>
+      <p:nvGrpSpPr>
+        <p:cNvPr id="1" name=""/>
+        <p:cNvGrpSpPr/>
+        <p:nvPr/>
+      </p:nvGrpSpPr>
+      <p:grpSpPr/>
+      <p:sp>
+        <p:nvSpPr>
+          <p:cNvPr id="2" name="Rectangle 1"/>
+          <p:cNvSpPr/>
+          <p:nvPr/>
+        </p:nvSpPr>
+        <p:spPr>
+          <a:xfrm>
+            <a:off x="0" y="0"/>
+            <a:ext cx="12191695" cy="1051560"/>
+          </a:xfrm>
+          <a:prstGeom prst="rect">
+            <a:avLst/>
+          </a:prstGeom>
+          <a:solidFill>
+            <a:srgbClr val="1F4E79"/>
+          </a:solidFill>
+          <a:ln>
+            <a:noFill/>
+          </a:ln>
+          <a:effectLst/>
+        </p:spPr>
+        <p:style>
+          <a:lnRef idx="1">
+            <a:schemeClr val="accent1"/>
+          </a:lnRef>
+          <a:fillRef idx="3">
+            <a:schemeClr val="accent1"/>
+          </a:fillRef>
+          <a:effectRef idx="2">
+            <a:schemeClr val="accent1"/>
+          </a:effectRef>
+          <a:fontRef idx="minor">
+            <a:schemeClr val="lt1"/>
+          </a:fontRef>
+        </p:style>
+        <p:txBody>
+          <a:bodyPr rtlCol="0" anchor="ctr"/>
+          <a:lstStyle/>
+          <a:p>
+            <a:pPr algn="ctr"/>
+          </a:p>
+        </p:txBody>
+      </p:sp>
+      <p:sp>
+        <p:nvSpPr>
+          <p:cNvPr id="3" name="TextBox 2"/>
+          <p:cNvSpPr txBox="1"/>
+          <p:nvPr/>
+        </p:nvSpPr>
+        <p:spPr>
+          <a:xfrm>
+            <a:off x="548640" y="164592"/>
+            <a:ext cx="10058400" cy="731520"/>
+          </a:xfrm>
+          <a:prstGeom prst="rect">
+            <a:avLst/>
+          </a:prstGeom>
+          <a:noFill/>
+        </p:spPr>
+        <p:txBody>
+          <a:bodyPr wrap="square" anchor="ctr">
+            <a:spAutoFit/>
+          </a:bodyPr>
+          <a:lstStyle/>
+          <a:p>
+            <a:pPr algn="l"/>
+            <a:r>
+              <a:rPr sz="2800" b="1" i="0">
+                <a:solidFill>
+                  <a:srgbClr val="FFFFFF"/>
+                </a:solidFill>
+                <a:latin typeface="Calibri"/>
+              </a:rPr>
+              <a:t>Canlı Kanıt — Uygulama Çalışıyor</a:t>
+            </a:r>
+          </a:p>
+        </p:txBody>
+      </p:sp>
+      <p:sp>
+        <p:nvSpPr>
+          <p:cNvPr id="4" name="TextBox 3"/>
+          <p:cNvSpPr txBox="1"/>
+          <p:nvPr/>
+        </p:nvSpPr>
+        <p:spPr>
+          <a:xfrm>
+            <a:off x="11155680" y="164592"/>
+            <a:ext cx="822960" cy="731520"/>
+          </a:xfrm>
+          <a:prstGeom prst="rect">
+            <a:avLst/>
+          </a:prstGeom>
+          <a:noFill/>
+        </p:spPr>
+        <p:txBody>
+          <a:bodyPr wrap="square" anchor="ctr">
+            <a:spAutoFit/>
+          </a:bodyPr>
+          <a:lstStyle/>
+          <a:p>
+            <a:pPr algn="r"/>
+            <a:r>
+              <a:rPr sz="1600" b="1" i="0">
+                <a:solidFill>
+                  <a:srgbClr val="BBCCEE"/>
+                </a:solidFill>
+                <a:latin typeface="Calibri"/>
+              </a:rPr>
+              <a:t>09</a:t>
+            </a:r>
+          </a:p>
+        </p:txBody>
+      </p:sp>
+      <p:sp>
+        <p:nvSpPr>
+          <p:cNvPr id="5" name="TextBox 4"/>
+          <p:cNvSpPr txBox="1"/>
+          <p:nvPr/>
+        </p:nvSpPr>
+        <p:spPr>
+          <a:xfrm>
+            <a:off x="640080" y="1234440"/>
+            <a:ext cx="5394960" cy="457200"/>
+          </a:xfrm>
+          <a:prstGeom prst="rect">
+            <a:avLst/>
+          </a:prstGeom>
+          <a:noFill/>
+        </p:spPr>
+        <p:txBody>
+          <a:bodyPr wrap="square" anchor="t">
+            <a:spAutoFit/>
+          </a:bodyPr>
+          <a:lstStyle/>
+          <a:p>
+            <a:pPr algn="l"/>
+            <a:r>
+              <a:rPr sz="1500" b="1" i="0">
+                <a:solidFill>
+                  <a:srgbClr val="1F4E79"/>
+                </a:solidFill>
+                <a:latin typeface="Calibri"/>
+              </a:rPr>
+              <a:t>Başlangıç: modeller + DB tabloları + Uvicorn</a:t>
+            </a:r>
+          </a:p>
+        </p:txBody>
+      </p:sp>
+      <p:sp>
+        <p:nvSpPr>
+          <p:cNvPr id="6" name="Rectangle 5"/>
+          <p:cNvSpPr/>
+          <p:nvPr/>
+        </p:nvSpPr>
+        <p:spPr>
+          <a:xfrm>
+            <a:off x="640080" y="1737360"/>
+            <a:ext cx="5394960" cy="4480560"/>
+          </a:xfrm>
+          <a:prstGeom prst="rect">
+            <a:avLst/>
+          </a:prstGeom>
+          <a:solidFill>
+            <a:srgbClr val="FFFFFF"/>
+          </a:solidFill>
+          <a:ln w="12700">
+            <a:solidFill>
+              <a:srgbClr val="B0BCCC"/>
+            </a:solidFill>
+          </a:ln>
+          <a:effectLst/>
+        </p:spPr>
+        <p:style>
+          <a:lnRef idx="1">
+            <a:schemeClr val="accent1"/>
+          </a:lnRef>
+          <a:fillRef idx="3">
+            <a:schemeClr val="accent1"/>
+          </a:fillRef>
+          <a:effectRef idx="2">
+            <a:schemeClr val="accent1"/>
+          </a:effectRef>
+          <a:fontRef idx="minor">
+            <a:schemeClr val="lt1"/>
+          </a:fontRef>
+        </p:style>
+        <p:txBody>
+          <a:bodyPr rtlCol="0" anchor="ctr"/>
+          <a:lstStyle/>
+          <a:p>
+            <a:pPr algn="ctr"/>
+          </a:p>
+        </p:txBody>
+      </p:sp>
+      <p:pic>
+        <p:nvPicPr>
+          <p:cNvPr id="7" name="Picture 6" descr="01_uygulama_calisiyor.png"/>
+          <p:cNvPicPr>
+            <a:picLocks noChangeAspect="1"/>
+          </p:cNvPicPr>
+          <p:nvPr/>
+        </p:nvPicPr>
+        <p:blipFill>
+          <a:blip r:embed="rId2"/>
+          <a:stretch>
+            <a:fillRect/>
+          </a:stretch>
+        </p:blipFill>
+        <p:spPr>
+          <a:xfrm>
+            <a:off x="640080" y="2460484"/>
+            <a:ext cx="5394960" cy="3034311"/>
+          </a:xfrm>
+          <a:prstGeom prst="rect">
+            <a:avLst/>
+          </a:prstGeom>
+        </p:spPr>
+      </p:pic>
+      <p:sp>
+        <p:nvSpPr>
+          <p:cNvPr id="8" name="TextBox 7"/>
+          <p:cNvSpPr txBox="1"/>
+          <p:nvPr/>
+        </p:nvSpPr>
+        <p:spPr>
+          <a:xfrm>
+            <a:off x="640080" y="5925312"/>
+            <a:ext cx="5394960" cy="274320"/>
+          </a:xfrm>
+          <a:prstGeom prst="rect">
+            <a:avLst/>
+          </a:prstGeom>
+          <a:noFill/>
+        </p:spPr>
+        <p:txBody>
+          <a:bodyPr wrap="square" anchor="t">
+            <a:spAutoFit/>
+          </a:bodyPr>
+          <a:lstStyle/>
+          <a:p>
+            <a:pPr algn="r"/>
+            <a:r>
+              <a:rPr sz="900" b="1" i="0">
+                <a:solidFill>
+                  <a:srgbClr val="2E863A"/>
+                </a:solidFill>
+                <a:latin typeface="Calibri"/>
+              </a:rPr>
+              <a:t>✔ gerçek ekran görüntüsü</a:t>
+            </a:r>
+          </a:p>
+        </p:txBody>
+      </p:sp>
+      <p:sp>
+        <p:nvSpPr>
+          <p:cNvPr id="9" name="TextBox 8"/>
+          <p:cNvSpPr txBox="1"/>
+          <p:nvPr/>
+        </p:nvSpPr>
+        <p:spPr>
+          <a:xfrm>
+            <a:off x="6309360" y="1234440"/>
+            <a:ext cx="5394960" cy="457200"/>
+          </a:xfrm>
+          <a:prstGeom prst="rect">
+            <a:avLst/>
+          </a:prstGeom>
+          <a:noFill/>
+        </p:spPr>
+        <p:txBody>
+          <a:bodyPr wrap="square" anchor="t">
+            <a:spAutoFit/>
+          </a:bodyPr>
+          <a:lstStyle/>
+          <a:p>
+            <a:pPr algn="l"/>
+            <a:r>
+              <a:rPr sz="1500" b="1" i="0">
+                <a:solidFill>
+                  <a:srgbClr val="1F4E79"/>
+                </a:solidFill>
+                <a:latin typeface="Calibri"/>
+              </a:rPr>
+              <a:t>FastAPI Swagger /docs — tüm uçlar</a:t>
+            </a:r>
+          </a:p>
+        </p:txBody>
+      </p:sp>
+      <p:sp>
+        <p:nvSpPr>
+          <p:cNvPr id="10" name="Rectangle 9"/>
+          <p:cNvSpPr/>
+          <p:nvPr/>
+        </p:nvSpPr>
+        <p:spPr>
+          <a:xfrm>
+            <a:off x="6309360" y="1737360"/>
+            <a:ext cx="5394960" cy="4480560"/>
+          </a:xfrm>
+          <a:prstGeom prst="rect">
+            <a:avLst/>
+          </a:prstGeom>
+          <a:solidFill>
+            <a:srgbClr val="FFFFFF"/>
+          </a:solidFill>
+          <a:ln w="12700">
+            <a:solidFill>
+              <a:srgbClr val="B0BCCC"/>
+            </a:solidFill>
+          </a:ln>
+          <a:effectLst/>
+        </p:spPr>
+        <p:style>
+          <a:lnRef idx="1">
+            <a:schemeClr val="accent1"/>
+          </a:lnRef>
+          <a:fillRef idx="3">
+            <a:schemeClr val="accent1"/>
+          </a:fillRef>
+          <a:effectRef idx="2">
+            <a:schemeClr val="accent1"/>
+          </a:effectRef>
+          <a:fontRef idx="minor">
+            <a:schemeClr val="lt1"/>
+          </a:fontRef>
+        </p:style>
+        <p:txBody>
+          <a:bodyPr rtlCol="0" anchor="ctr"/>
+          <a:lstStyle/>
+          <a:p>
+            <a:pPr algn="ctr"/>
+          </a:p>
+        </p:txBody>
+      </p:sp>
+      <p:pic>
+        <p:nvPicPr>
+          <p:cNvPr id="11" name="Picture 10" descr="02_swagger.png"/>
+          <p:cNvPicPr>
+            <a:picLocks noChangeAspect="1"/>
+          </p:cNvPicPr>
+          <p:nvPr/>
+        </p:nvPicPr>
+        <p:blipFill>
+          <a:blip r:embed="rId3"/>
+          <a:stretch>
+            <a:fillRect/>
+          </a:stretch>
+        </p:blipFill>
+        <p:spPr>
+          <a:xfrm>
+            <a:off x="6309360" y="2499607"/>
+            <a:ext cx="5394960" cy="2956065"/>
+          </a:xfrm>
+          <a:prstGeom prst="rect">
+            <a:avLst/>
+          </a:prstGeom>
+        </p:spPr>
+      </p:pic>
+      <p:sp>
+        <p:nvSpPr>
+          <p:cNvPr id="12" name="TextBox 11"/>
+          <p:cNvSpPr txBox="1"/>
+          <p:nvPr/>
+        </p:nvSpPr>
+        <p:spPr>
+          <a:xfrm>
+            <a:off x="6309360" y="5925312"/>
+            <a:ext cx="5394960" cy="274320"/>
+          </a:xfrm>
+          <a:prstGeom prst="rect">
+            <a:avLst/>
+          </a:prstGeom>
+          <a:noFill/>
+        </p:spPr>
+        <p:txBody>
+          <a:bodyPr wrap="square" anchor="t">
+            <a:spAutoFit/>
+          </a:bodyPr>
+          <a:lstStyle/>
+          <a:p>
+            <a:pPr algn="r"/>
+            <a:r>
+              <a:rPr sz="900" b="1" i="0">
+                <a:solidFill>
+                  <a:srgbClr val="2E863A"/>
+                </a:solidFill>
+                <a:latin typeface="Calibri"/>
+              </a:rPr>
+              <a:t>✔ gerçek ekran görüntüsü</a:t>
+            </a:r>
+          </a:p>
+        </p:txBody>
+      </p:sp>
+    </p:spTree>
+  </p:cSld>
+  <p:clrMapOvr>
+    <a:masterClrMapping/>
+  </p:clrMapOvr>
+</p:sld>
+</file>
+
+<file path=ppt/slides/slide11.xml><?xml version="1.0" encoding="utf-8"?>
+<p:sld xmlns:a="http://schemas.openxmlformats.org/drawingml/2006/main" xmlns:p="http://schemas.openxmlformats.org/presentationml/2006/main" xmlns:r="http://schemas.openxmlformats.org/officeDocument/2006/relationships">
+  <p:cSld>
+    <p:spTree>
+      <p:nvGrpSpPr>
+        <p:cNvPr id="1" name=""/>
+        <p:cNvGrpSpPr/>
+        <p:nvPr/>
+      </p:nvGrpSpPr>
+      <p:grpSpPr/>
+      <p:sp>
+        <p:nvSpPr>
+          <p:cNvPr id="2" name="Rectangle 1"/>
+          <p:cNvSpPr/>
+          <p:nvPr/>
+        </p:nvSpPr>
+        <p:spPr>
+          <a:xfrm>
+            <a:off x="0" y="0"/>
+            <a:ext cx="12191695" cy="1051560"/>
+          </a:xfrm>
+          <a:prstGeom prst="rect">
+            <a:avLst/>
+          </a:prstGeom>
+          <a:solidFill>
+            <a:srgbClr val="1F4E79"/>
+          </a:solidFill>
+          <a:ln>
+            <a:noFill/>
+          </a:ln>
+          <a:effectLst/>
+        </p:spPr>
+        <p:style>
+          <a:lnRef idx="1">
+            <a:schemeClr val="accent1"/>
+          </a:lnRef>
+          <a:fillRef idx="3">
+            <a:schemeClr val="accent1"/>
+          </a:fillRef>
+          <a:effectRef idx="2">
+            <a:schemeClr val="accent1"/>
+          </a:effectRef>
+          <a:fontRef idx="minor">
+            <a:schemeClr val="lt1"/>
+          </a:fontRef>
+        </p:style>
+        <p:txBody>
+          <a:bodyPr rtlCol="0" anchor="ctr"/>
+          <a:lstStyle/>
+          <a:p>
+            <a:pPr algn="ctr"/>
+          </a:p>
+        </p:txBody>
+      </p:sp>
+      <p:sp>
+        <p:nvSpPr>
+          <p:cNvPr id="3" name="TextBox 2"/>
+          <p:cNvSpPr txBox="1"/>
+          <p:nvPr/>
+        </p:nvSpPr>
+        <p:spPr>
+          <a:xfrm>
+            <a:off x="548640" y="164592"/>
+            <a:ext cx="10058400" cy="731520"/>
+          </a:xfrm>
+          <a:prstGeom prst="rect">
+            <a:avLst/>
+          </a:prstGeom>
+          <a:noFill/>
+        </p:spPr>
+        <p:txBody>
+          <a:bodyPr wrap="square" anchor="ctr">
+            <a:spAutoFit/>
+          </a:bodyPr>
+          <a:lstStyle/>
+          <a:p>
+            <a:pPr algn="l"/>
+            <a:r>
+              <a:rPr sz="2800" b="1" i="0">
+                <a:solidFill>
+                  <a:srgbClr val="FFFFFF"/>
+                </a:solidFill>
+                <a:latin typeface="Calibri"/>
+              </a:rPr>
+              <a:t>Canlı Kanıt — API Uçları (Swagger)</a:t>
+            </a:r>
+          </a:p>
+        </p:txBody>
+      </p:sp>
+      <p:sp>
+        <p:nvSpPr>
+          <p:cNvPr id="4" name="TextBox 3"/>
+          <p:cNvSpPr txBox="1"/>
+          <p:nvPr/>
+        </p:nvSpPr>
+        <p:spPr>
+          <a:xfrm>
+            <a:off x="11155680" y="164592"/>
+            <a:ext cx="822960" cy="731520"/>
+          </a:xfrm>
+          <a:prstGeom prst="rect">
+            <a:avLst/>
+          </a:prstGeom>
+          <a:noFill/>
+        </p:spPr>
+        <p:txBody>
+          <a:bodyPr wrap="square" anchor="ctr">
+            <a:spAutoFit/>
+          </a:bodyPr>
+          <a:lstStyle/>
+          <a:p>
+            <a:pPr algn="r"/>
+            <a:r>
+              <a:rPr sz="1600" b="1" i="0">
+                <a:solidFill>
+                  <a:srgbClr val="BBCCEE"/>
+                </a:solidFill>
+                <a:latin typeface="Calibri"/>
+              </a:rPr>
+              <a:t>10</a:t>
+            </a:r>
+          </a:p>
+        </p:txBody>
+      </p:sp>
+      <p:sp>
+        <p:nvSpPr>
+          <p:cNvPr id="5" name="TextBox 4"/>
+          <p:cNvSpPr txBox="1"/>
+          <p:nvPr/>
+        </p:nvSpPr>
+        <p:spPr>
+          <a:xfrm>
+            <a:off x="640080" y="1234440"/>
+            <a:ext cx="5394960" cy="457200"/>
+          </a:xfrm>
+          <a:prstGeom prst="rect">
+            <a:avLst/>
+          </a:prstGeom>
+          <a:noFill/>
+        </p:spPr>
+        <p:txBody>
+          <a:bodyPr wrap="square" anchor="t">
+            <a:spAutoFit/>
+          </a:bodyPr>
+          <a:lstStyle/>
+          <a:p>
+            <a:pPr algn="l"/>
+            <a:r>
+              <a:rPr sz="1400" b="1" i="0">
+                <a:solidFill>
+                  <a:srgbClr val="1F4E79"/>
+                </a:solidFill>
+                <a:latin typeface="Calibri"/>
+              </a:rPr>
+              <a:t>POST /prediction/advertising — istek gövdesi &amp; şema</a:t>
+            </a:r>
+          </a:p>
+        </p:txBody>
+      </p:sp>
+      <p:sp>
+        <p:nvSpPr>
+          <p:cNvPr id="6" name="Rectangle 5"/>
+          <p:cNvSpPr/>
+          <p:nvPr/>
+        </p:nvSpPr>
+        <p:spPr>
+          <a:xfrm>
+            <a:off x="640080" y="1737360"/>
+            <a:ext cx="5394960" cy="4480560"/>
+          </a:xfrm>
+          <a:prstGeom prst="rect">
+            <a:avLst/>
+          </a:prstGeom>
+          <a:solidFill>
+            <a:srgbClr val="FFFFFF"/>
+          </a:solidFill>
+          <a:ln w="12700">
+            <a:solidFill>
+              <a:srgbClr val="B0BCCC"/>
+            </a:solidFill>
+          </a:ln>
+          <a:effectLst/>
+        </p:spPr>
+        <p:style>
+          <a:lnRef idx="1">
+            <a:schemeClr val="accent1"/>
+          </a:lnRef>
+          <a:fillRef idx="3">
+            <a:schemeClr val="accent1"/>
+          </a:fillRef>
+          <a:effectRef idx="2">
+            <a:schemeClr val="accent1"/>
+          </a:effectRef>
+          <a:fontRef idx="minor">
+            <a:schemeClr val="lt1"/>
+          </a:fontRef>
+        </p:style>
+        <p:txBody>
+          <a:bodyPr rtlCol="0" anchor="ctr"/>
+          <a:lstStyle/>
+          <a:p>
+            <a:pPr algn="ctr"/>
+          </a:p>
+        </p:txBody>
+      </p:sp>
+      <p:pic>
+        <p:nvPicPr>
+          <p:cNvPr id="7" name="Picture 6" descr="03_advertising.png"/>
+          <p:cNvPicPr>
+            <a:picLocks noChangeAspect="1"/>
+          </p:cNvPicPr>
+          <p:nvPr/>
+        </p:nvPicPr>
+        <p:blipFill>
+          <a:blip r:embed="rId2"/>
+          <a:stretch>
+            <a:fillRect/>
+          </a:stretch>
+        </p:blipFill>
+        <p:spPr>
+          <a:xfrm>
+            <a:off x="640080" y="2485538"/>
+            <a:ext cx="5394960" cy="2984203"/>
+          </a:xfrm>
+          <a:prstGeom prst="rect">
+            <a:avLst/>
+          </a:prstGeom>
+        </p:spPr>
+      </p:pic>
+      <p:sp>
+        <p:nvSpPr>
+          <p:cNvPr id="8" name="TextBox 7"/>
+          <p:cNvSpPr txBox="1"/>
+          <p:nvPr/>
+        </p:nvSpPr>
+        <p:spPr>
+          <a:xfrm>
+            <a:off x="640080" y="5925312"/>
+            <a:ext cx="5394960" cy="274320"/>
+          </a:xfrm>
+          <a:prstGeom prst="rect">
+            <a:avLst/>
+          </a:prstGeom>
+          <a:noFill/>
+        </p:spPr>
+        <p:txBody>
+          <a:bodyPr wrap="square" anchor="t">
+            <a:spAutoFit/>
+          </a:bodyPr>
+          <a:lstStyle/>
+          <a:p>
+            <a:pPr algn="r"/>
+            <a:r>
+              <a:rPr sz="900" b="1" i="0">
+                <a:solidFill>
+                  <a:srgbClr val="2E863A"/>
+                </a:solidFill>
+                <a:latin typeface="Calibri"/>
+              </a:rPr>
+              <a:t>✔ gerçek ekran görüntüsü</a:t>
+            </a:r>
+          </a:p>
+        </p:txBody>
+      </p:sp>
+      <p:sp>
+        <p:nvSpPr>
+          <p:cNvPr id="9" name="TextBox 8"/>
+          <p:cNvSpPr txBox="1"/>
+          <p:nvPr/>
+        </p:nvSpPr>
+        <p:spPr>
+          <a:xfrm>
+            <a:off x="6309360" y="1234440"/>
+            <a:ext cx="5394960" cy="457200"/>
+          </a:xfrm>
+          <a:prstGeom prst="rect">
+            <a:avLst/>
+          </a:prstGeom>
+          <a:noFill/>
+        </p:spPr>
+        <p:txBody>
+          <a:bodyPr wrap="square" anchor="t">
+            <a:spAutoFit/>
+          </a:bodyPr>
+          <a:lstStyle/>
+          <a:p>
+            <a:pPr algn="l"/>
+            <a:r>
+              <a:rPr sz="1400" b="1" i="0">
+                <a:solidFill>
+                  <a:srgbClr val="1F4E79"/>
+                </a:solidFill>
+                <a:latin typeface="Calibri"/>
+              </a:rPr>
+              <a:t>GET /metrics &amp; /healthz — izleme/probe uçları</a:t>
+            </a:r>
+          </a:p>
+        </p:txBody>
+      </p:sp>
+      <p:sp>
+        <p:nvSpPr>
+          <p:cNvPr id="10" name="Rectangle 9"/>
+          <p:cNvSpPr/>
+          <p:nvPr/>
+        </p:nvSpPr>
+        <p:spPr>
+          <a:xfrm>
+            <a:off x="6309360" y="1737360"/>
+            <a:ext cx="5394960" cy="4480560"/>
+          </a:xfrm>
+          <a:prstGeom prst="rect">
+            <a:avLst/>
+          </a:prstGeom>
+          <a:solidFill>
+            <a:srgbClr val="FFFFFF"/>
+          </a:solidFill>
+          <a:ln w="12700">
+            <a:solidFill>
+              <a:srgbClr val="B0BCCC"/>
+            </a:solidFill>
+          </a:ln>
+          <a:effectLst/>
+        </p:spPr>
+        <p:style>
+          <a:lnRef idx="1">
+            <a:schemeClr val="accent1"/>
+          </a:lnRef>
+          <a:fillRef idx="3">
+            <a:schemeClr val="accent1"/>
+          </a:fillRef>
+          <a:effectRef idx="2">
+            <a:schemeClr val="accent1"/>
+          </a:effectRef>
+          <a:fontRef idx="minor">
+            <a:schemeClr val="lt1"/>
+          </a:fontRef>
+        </p:style>
+        <p:txBody>
+          <a:bodyPr rtlCol="0" anchor="ctr"/>
+          <a:lstStyle/>
+          <a:p>
+            <a:pPr algn="ctr"/>
+          </a:p>
+        </p:txBody>
+      </p:sp>
+      <p:pic>
+        <p:nvPicPr>
+          <p:cNvPr id="11" name="Picture 10" descr="04_metrics_endpoint.png"/>
+          <p:cNvPicPr>
+            <a:picLocks noChangeAspect="1"/>
+          </p:cNvPicPr>
+          <p:nvPr/>
+        </p:nvPicPr>
+        <p:blipFill>
+          <a:blip r:embed="rId3"/>
+          <a:stretch>
+            <a:fillRect/>
+          </a:stretch>
+        </p:blipFill>
+        <p:spPr>
+          <a:xfrm>
+            <a:off x="6309360" y="2549395"/>
+            <a:ext cx="5394960" cy="2856489"/>
+          </a:xfrm>
+          <a:prstGeom prst="rect">
+            <a:avLst/>
+          </a:prstGeom>
+        </p:spPr>
+      </p:pic>
+      <p:sp>
+        <p:nvSpPr>
+          <p:cNvPr id="12" name="TextBox 11"/>
+          <p:cNvSpPr txBox="1"/>
+          <p:nvPr/>
+        </p:nvSpPr>
+        <p:spPr>
+          <a:xfrm>
+            <a:off x="6309360" y="5925312"/>
+            <a:ext cx="5394960" cy="274320"/>
+          </a:xfrm>
+          <a:prstGeom prst="rect">
+            <a:avLst/>
+          </a:prstGeom>
+          <a:noFill/>
+        </p:spPr>
+        <p:txBody>
+          <a:bodyPr wrap="square" anchor="t">
+            <a:spAutoFit/>
+          </a:bodyPr>
+          <a:lstStyle/>
+          <a:p>
+            <a:pPr algn="r"/>
+            <a:r>
+              <a:rPr sz="900" b="1" i="0">
+                <a:solidFill>
+                  <a:srgbClr val="2E863A"/>
+                </a:solidFill>
+                <a:latin typeface="Calibri"/>
+              </a:rPr>
+              <a:t>✔ gerçek ekran görüntüsü</a:t>
+            </a:r>
+          </a:p>
+        </p:txBody>
+      </p:sp>
+    </p:spTree>
+  </p:cSld>
+  <p:clrMapOvr>
+    <a:masterClrMapping/>
+  </p:clrMapOvr>
+</p:sld>
+</file>
+
+<file path=ppt/slides/slide12.xml><?xml version="1.0" encoding="utf-8"?>
+<p:sld xmlns:a="http://schemas.openxmlformats.org/drawingml/2006/main" xmlns:p="http://schemas.openxmlformats.org/presentationml/2006/main" xmlns:r="http://schemas.openxmlformats.org/officeDocument/2006/relationships">
+  <p:cSld>
+    <p:spTree>
+      <p:nvGrpSpPr>
+        <p:cNvPr id="1" name=""/>
+        <p:cNvGrpSpPr/>
+        <p:nvPr/>
+      </p:nvGrpSpPr>
+      <p:grpSpPr/>
+      <p:sp>
+        <p:nvSpPr>
+          <p:cNvPr id="2" name="Rectangle 1"/>
+          <p:cNvSpPr/>
+          <p:nvPr/>
+        </p:nvSpPr>
+        <p:spPr>
+          <a:xfrm>
+            <a:off x="0" y="0"/>
+            <a:ext cx="12191695" cy="1051560"/>
+          </a:xfrm>
+          <a:prstGeom prst="rect">
+            <a:avLst/>
+          </a:prstGeom>
+          <a:solidFill>
+            <a:srgbClr val="1F4E79"/>
+          </a:solidFill>
+          <a:ln>
+            <a:noFill/>
+          </a:ln>
+          <a:effectLst/>
+        </p:spPr>
+        <p:style>
+          <a:lnRef idx="1">
+            <a:schemeClr val="accent1"/>
+          </a:lnRef>
+          <a:fillRef idx="3">
+            <a:schemeClr val="accent1"/>
+          </a:fillRef>
+          <a:effectRef idx="2">
+            <a:schemeClr val="accent1"/>
+          </a:effectRef>
+          <a:fontRef idx="minor">
+            <a:schemeClr val="lt1"/>
+          </a:fontRef>
+        </p:style>
+        <p:txBody>
+          <a:bodyPr rtlCol="0" anchor="ctr"/>
+          <a:lstStyle/>
+          <a:p>
+            <a:pPr algn="ctr"/>
+          </a:p>
+        </p:txBody>
+      </p:sp>
+      <p:sp>
+        <p:nvSpPr>
+          <p:cNvPr id="3" name="TextBox 2"/>
+          <p:cNvSpPr txBox="1"/>
+          <p:nvPr/>
+        </p:nvSpPr>
+        <p:spPr>
+          <a:xfrm>
+            <a:off x="548640" y="164592"/>
+            <a:ext cx="10058400" cy="731520"/>
+          </a:xfrm>
+          <a:prstGeom prst="rect">
+            <a:avLst/>
+          </a:prstGeom>
+          <a:noFill/>
+        </p:spPr>
+        <p:txBody>
+          <a:bodyPr wrap="square" anchor="ctr">
+            <a:spAutoFit/>
+          </a:bodyPr>
+          <a:lstStyle/>
+          <a:p>
+            <a:pPr algn="l"/>
+            <a:r>
+              <a:rPr sz="2800" b="1" i="0">
+                <a:solidFill>
+                  <a:srgbClr val="FFFFFF"/>
+                </a:solidFill>
+                <a:latin typeface="Calibri"/>
+              </a:rPr>
+              <a:t>Canlı Kanıt — CI/CD (GitHub Actions + GHCR)</a:t>
+            </a:r>
+          </a:p>
+        </p:txBody>
+      </p:sp>
+      <p:sp>
+        <p:nvSpPr>
+          <p:cNvPr id="4" name="TextBox 3"/>
+          <p:cNvSpPr txBox="1"/>
+          <p:nvPr/>
+        </p:nvSpPr>
+        <p:spPr>
+          <a:xfrm>
+            <a:off x="11155680" y="164592"/>
+            <a:ext cx="822960" cy="731520"/>
+          </a:xfrm>
+          <a:prstGeom prst="rect">
+            <a:avLst/>
+          </a:prstGeom>
+          <a:noFill/>
+        </p:spPr>
+        <p:txBody>
+          <a:bodyPr wrap="square" anchor="ctr">
+            <a:spAutoFit/>
+          </a:bodyPr>
+          <a:lstStyle/>
+          <a:p>
+            <a:pPr algn="r"/>
+            <a:r>
+              <a:rPr sz="1600" b="1" i="0">
+                <a:solidFill>
+                  <a:srgbClr val="BBCCEE"/>
+                </a:solidFill>
+                <a:latin typeface="Calibri"/>
+              </a:rPr>
+              <a:t>11</a:t>
+            </a:r>
+          </a:p>
+        </p:txBody>
+      </p:sp>
+      <p:sp>
+        <p:nvSpPr>
+          <p:cNvPr id="5" name="TextBox 4"/>
+          <p:cNvSpPr txBox="1"/>
+          <p:nvPr/>
+        </p:nvSpPr>
+        <p:spPr>
+          <a:xfrm>
+            <a:off x="640080" y="1234440"/>
+            <a:ext cx="5394960" cy="457200"/>
+          </a:xfrm>
+          <a:prstGeom prst="rect">
+            <a:avLst/>
+          </a:prstGeom>
+          <a:noFill/>
+        </p:spPr>
+        <p:txBody>
+          <a:bodyPr wrap="square" anchor="t">
+            <a:spAutoFit/>
+          </a:bodyPr>
+          <a:lstStyle/>
+          <a:p>
+            <a:pPr algn="l"/>
+            <a:r>
+              <a:rPr sz="1500" b="1" i="0">
+                <a:solidFill>
+                  <a:srgbClr val="1F4E79"/>
+                </a:solidFill>
+                <a:latin typeface="Calibri"/>
+              </a:rPr>
+              <a:t>GitHub Actions — lint / build / manifest (yeşil)</a:t>
+            </a:r>
+          </a:p>
+        </p:txBody>
+      </p:sp>
+      <p:sp>
+        <p:nvSpPr>
+          <p:cNvPr id="6" name="Rectangle 5"/>
+          <p:cNvSpPr/>
+          <p:nvPr/>
+        </p:nvSpPr>
+        <p:spPr>
+          <a:xfrm>
+            <a:off x="640080" y="1737360"/>
+            <a:ext cx="5394960" cy="4480560"/>
+          </a:xfrm>
+          <a:prstGeom prst="rect">
+            <a:avLst/>
+          </a:prstGeom>
+          <a:solidFill>
+            <a:srgbClr val="E8ECF2"/>
+          </a:solidFill>
+          <a:ln w="19050">
+            <a:solidFill>
+              <a:srgbClr val="B0BCCC"/>
+            </a:solidFill>
+          </a:ln>
+          <a:effectLst/>
+        </p:spPr>
+        <p:style>
+          <a:lnRef idx="1">
+            <a:schemeClr val="accent1"/>
+          </a:lnRef>
+          <a:fillRef idx="3">
+            <a:schemeClr val="accent1"/>
+          </a:fillRef>
+          <a:effectRef idx="2">
+            <a:schemeClr val="accent1"/>
+          </a:effectRef>
+          <a:fontRef idx="minor">
+            <a:schemeClr val="lt1"/>
+          </a:fontRef>
+        </p:style>
+        <p:txBody>
+          <a:bodyPr rtlCol="0" anchor="ctr"/>
+          <a:lstStyle/>
+          <a:p>
+            <a:pPr algn="ctr"/>
+          </a:p>
+        </p:txBody>
+      </p:sp>
+      <p:sp>
+        <p:nvSpPr>
+          <p:cNvPr id="7" name="TextBox 6"/>
+          <p:cNvSpPr txBox="1"/>
+          <p:nvPr/>
+        </p:nvSpPr>
+        <p:spPr>
+          <a:xfrm>
+            <a:off x="640080" y="3520440"/>
+            <a:ext cx="5394960" cy="457200"/>
+          </a:xfrm>
+          <a:prstGeom prst="rect">
+            <a:avLst/>
+          </a:prstGeom>
+          <a:noFill/>
+        </p:spPr>
+        <p:txBody>
+          <a:bodyPr wrap="square" anchor="ctr">
+            <a:spAutoFit/>
+          </a:bodyPr>
+          <a:lstStyle/>
+          <a:p>
+            <a:pPr algn="ctr"/>
+            <a:r>
+              <a:rPr sz="1500" b="1" i="0">
+                <a:solidFill>
+                  <a:srgbClr val="6A788A"/>
+                </a:solidFill>
+                <a:latin typeface="Calibri"/>
+              </a:rPr>
+              <a:t>🖼  GitHub Actions çalışması</a:t>
+            </a:r>
+          </a:p>
+        </p:txBody>
+      </p:sp>
+      <p:sp>
+        <p:nvSpPr>
+          <p:cNvPr id="8" name="TextBox 7"/>
+          <p:cNvSpPr txBox="1"/>
+          <p:nvPr/>
+        </p:nvSpPr>
+        <p:spPr>
+          <a:xfrm>
+            <a:off x="640080" y="4114800"/>
+            <a:ext cx="5394960" cy="457200"/>
+          </a:xfrm>
+          <a:prstGeom prst="rect">
+            <a:avLst/>
+          </a:prstGeom>
+          <a:noFill/>
+        </p:spPr>
+        <p:txBody>
+          <a:bodyPr wrap="square" anchor="t">
+            <a:spAutoFit/>
+          </a:bodyPr>
+          <a:lstStyle/>
+          <a:p>
+            <a:pPr algn="ctr"/>
+            <a:r>
+              <a:rPr sz="1100" b="0" i="1">
+                <a:solidFill>
+                  <a:srgbClr val="9AA6B4"/>
+                </a:solidFill>
+                <a:latin typeface="Calibri"/>
+              </a:rPr>
+              <a:t>(screenshots/05_github_actions.png)</a:t>
+            </a:r>
+          </a:p>
+        </p:txBody>
+      </p:sp>
+      <p:sp>
+        <p:nvSpPr>
+          <p:cNvPr id="9" name="TextBox 8"/>
+          <p:cNvSpPr txBox="1"/>
+          <p:nvPr/>
+        </p:nvSpPr>
+        <p:spPr>
+          <a:xfrm>
+            <a:off x="6309360" y="1234440"/>
+            <a:ext cx="5394960" cy="457200"/>
+          </a:xfrm>
+          <a:prstGeom prst="rect">
+            <a:avLst/>
+          </a:prstGeom>
+          <a:noFill/>
+        </p:spPr>
+        <p:txBody>
+          <a:bodyPr wrap="square" anchor="t">
+            <a:spAutoFit/>
+          </a:bodyPr>
+          <a:lstStyle/>
+          <a:p>
+            <a:pPr algn="l"/>
+            <a:r>
+              <a:rPr sz="1500" b="1" i="0">
+                <a:solidFill>
+                  <a:srgbClr val="1F4E79"/>
+                </a:solidFill>
+                <a:latin typeface="Calibri"/>
+              </a:rPr>
+              <a:t>GHCR — CI'ın ürettiği konteyner imajı</a:t>
+            </a:r>
+          </a:p>
+        </p:txBody>
+      </p:sp>
+      <p:sp>
+        <p:nvSpPr>
+          <p:cNvPr id="10" name="Rectangle 9"/>
+          <p:cNvSpPr/>
+          <p:nvPr/>
+        </p:nvSpPr>
+        <p:spPr>
+          <a:xfrm>
+            <a:off x="6309360" y="1737360"/>
+            <a:ext cx="5394960" cy="4480560"/>
+          </a:xfrm>
+          <a:prstGeom prst="rect">
+            <a:avLst/>
+          </a:prstGeom>
+          <a:solidFill>
+            <a:srgbClr val="E8ECF2"/>
+          </a:solidFill>
+          <a:ln w="19050">
+            <a:solidFill>
+              <a:srgbClr val="B0BCCC"/>
+            </a:solidFill>
+          </a:ln>
+          <a:effectLst/>
+        </p:spPr>
+        <p:style>
+          <a:lnRef idx="1">
+            <a:schemeClr val="accent1"/>
+          </a:lnRef>
+          <a:fillRef idx="3">
+            <a:schemeClr val="accent1"/>
+          </a:fillRef>
+          <a:effectRef idx="2">
+            <a:schemeClr val="accent1"/>
+          </a:effectRef>
+          <a:fontRef idx="minor">
+            <a:schemeClr val="lt1"/>
+          </a:fontRef>
+        </p:style>
+        <p:txBody>
+          <a:bodyPr rtlCol="0" anchor="ctr"/>
+          <a:lstStyle/>
+          <a:p>
+            <a:pPr algn="ctr"/>
+          </a:p>
+        </p:txBody>
+      </p:sp>
+      <p:sp>
+        <p:nvSpPr>
+          <p:cNvPr id="11" name="TextBox 10"/>
+          <p:cNvSpPr txBox="1"/>
+          <p:nvPr/>
+        </p:nvSpPr>
+        <p:spPr>
+          <a:xfrm>
+            <a:off x="6309360" y="3520440"/>
+            <a:ext cx="5394960" cy="457200"/>
+          </a:xfrm>
+          <a:prstGeom prst="rect">
+            <a:avLst/>
+          </a:prstGeom>
+          <a:noFill/>
+        </p:spPr>
+        <p:txBody>
+          <a:bodyPr wrap="square" anchor="ctr">
+            <a:spAutoFit/>
+          </a:bodyPr>
+          <a:lstStyle/>
+          <a:p>
+            <a:pPr algn="ctr"/>
+            <a:r>
+              <a:rPr sz="1500" b="1" i="0">
+                <a:solidFill>
+                  <a:srgbClr val="6A788A"/>
+                </a:solidFill>
+                <a:latin typeface="Calibri"/>
+              </a:rPr>
+              <a:t>🖼  GHCR paketi</a:t>
+            </a:r>
+          </a:p>
+        </p:txBody>
+      </p:sp>
+      <p:sp>
+        <p:nvSpPr>
+          <p:cNvPr id="12" name="TextBox 11"/>
+          <p:cNvSpPr txBox="1"/>
+          <p:nvPr/>
+        </p:nvSpPr>
+        <p:spPr>
+          <a:xfrm>
+            <a:off x="6309360" y="4114800"/>
+            <a:ext cx="5394960" cy="457200"/>
+          </a:xfrm>
+          <a:prstGeom prst="rect">
+            <a:avLst/>
+          </a:prstGeom>
+          <a:noFill/>
+        </p:spPr>
+        <p:txBody>
+          <a:bodyPr wrap="square" anchor="t">
+            <a:spAutoFit/>
+          </a:bodyPr>
+          <a:lstStyle/>
+          <a:p>
+            <a:pPr algn="ctr"/>
+            <a:r>
+              <a:rPr sz="1100" b="0" i="1">
+                <a:solidFill>
+                  <a:srgbClr val="9AA6B4"/>
+                </a:solidFill>
+                <a:latin typeface="Calibri"/>
+              </a:rPr>
+              <a:t>(screenshots/06_ghcr.png)</a:t>
+            </a:r>
+          </a:p>
+        </p:txBody>
+      </p:sp>
+    </p:spTree>
+  </p:cSld>
+  <p:clrMapOvr>
+    <a:masterClrMapping/>
+  </p:clrMapOvr>
+</p:sld>
+</file>
+
+<file path=ppt/slides/slide13.xml><?xml version="1.0" encoding="utf-8"?>
 <p:sld xmlns:a="http://schemas.openxmlformats.org/drawingml/2006/main" xmlns:p="http://schemas.openxmlformats.org/presentationml/2006/main" xmlns:r="http://schemas.openxmlformats.org/officeDocument/2006/relationships">
   <p:cSld>
     <p:spTree>

</xml_diff>